<commit_message>
Deck: corrige estouro de margem nas grades e quebra do titulo do slide 4
</commit_message>
<xml_diff>
--- a/Deck-Plano-Contingencia-LBCA.pptx
+++ b/Deck-Plano-Contingencia-LBCA.pptx
@@ -2151,7 +2151,7 @@
         <p:spPr>
           <a:xfrm>
             <a:off x="502920" y="3291840"/>
-            <a:ext cx="2734056" cy="1051560"/>
+            <a:ext cx="2658618" cy="1051560"/>
           </a:xfrm>
           <a:prstGeom prst="roundRect">
             <a:avLst>
@@ -2184,8 +2184,8 @@
         </p:nvSpPr>
         <p:spPr>
           <a:xfrm>
-            <a:off x="667512" y="3364992"/>
-            <a:ext cx="2404872" cy="896112"/>
+            <a:off x="649224" y="3364992"/>
+            <a:ext cx="2366010" cy="896112"/>
           </a:xfrm>
           <a:prstGeom prst="rect">
             <a:avLst/>
@@ -2238,8 +2238,8 @@
         </p:nvSpPr>
         <p:spPr>
           <a:xfrm>
-            <a:off x="3419856" y="3291840"/>
-            <a:ext cx="2734056" cy="1051560"/>
+            <a:off x="3344418" y="3291840"/>
+            <a:ext cx="2658618" cy="1051560"/>
           </a:xfrm>
           <a:prstGeom prst="roundRect">
             <a:avLst>
@@ -2272,8 +2272,8 @@
         </p:nvSpPr>
         <p:spPr>
           <a:xfrm>
-            <a:off x="3584448" y="3364992"/>
-            <a:ext cx="2404872" cy="896112"/>
+            <a:off x="3490722" y="3364992"/>
+            <a:ext cx="2366010" cy="896112"/>
           </a:xfrm>
           <a:prstGeom prst="rect">
             <a:avLst/>
@@ -2326,8 +2326,8 @@
         </p:nvSpPr>
         <p:spPr>
           <a:xfrm>
-            <a:off x="6336792" y="3291840"/>
-            <a:ext cx="2734056" cy="1051560"/>
+            <a:off x="6185916" y="3291840"/>
+            <a:ext cx="2658618" cy="1051560"/>
           </a:xfrm>
           <a:prstGeom prst="roundRect">
             <a:avLst>
@@ -2360,8 +2360,8 @@
         </p:nvSpPr>
         <p:spPr>
           <a:xfrm>
-            <a:off x="6501384" y="3364992"/>
-            <a:ext cx="2404872" cy="896112"/>
+            <a:off x="6332220" y="3364992"/>
+            <a:ext cx="2366010" cy="896112"/>
           </a:xfrm>
           <a:prstGeom prst="rect">
             <a:avLst/>
@@ -2414,8 +2414,8 @@
         </p:nvSpPr>
         <p:spPr>
           <a:xfrm>
-            <a:off x="9253728" y="3291840"/>
-            <a:ext cx="2734056" cy="1051560"/>
+            <a:off x="9027414" y="3291840"/>
+            <a:ext cx="2658618" cy="1051560"/>
           </a:xfrm>
           <a:prstGeom prst="roundRect">
             <a:avLst>
@@ -2448,8 +2448,8 @@
         </p:nvSpPr>
         <p:spPr>
           <a:xfrm>
-            <a:off x="9418320" y="3364992"/>
-            <a:ext cx="2404872" cy="896112"/>
+            <a:off x="9173718" y="3364992"/>
+            <a:ext cx="2366010" cy="896112"/>
           </a:xfrm>
           <a:prstGeom prst="rect">
             <a:avLst/>
@@ -2850,7 +2850,7 @@
         <p:spPr>
           <a:xfrm>
             <a:off x="502920" y="1371600"/>
-            <a:ext cx="3785616" cy="1664208"/>
+            <a:ext cx="3605784" cy="1664208"/>
           </a:xfrm>
           <a:prstGeom prst="roundRect">
             <a:avLst>
@@ -2928,7 +2928,7 @@
         <p:spPr>
           <a:xfrm>
             <a:off x="1161288" y="1536192"/>
-            <a:ext cx="2926080" cy="384048"/>
+            <a:ext cx="2764536" cy="384048"/>
           </a:xfrm>
           <a:prstGeom prst="rect">
             <a:avLst/>
@@ -2967,7 +2967,7 @@
         <p:spPr>
           <a:xfrm>
             <a:off x="685800" y="1993392"/>
-            <a:ext cx="3419856" cy="932688"/>
+            <a:ext cx="3240024" cy="932688"/>
           </a:xfrm>
           <a:prstGeom prst="rect">
             <a:avLst/>
@@ -3005,8 +3005,8 @@
         </p:nvSpPr>
         <p:spPr>
           <a:xfrm>
-            <a:off x="4471416" y="1371600"/>
-            <a:ext cx="3785616" cy="1664208"/>
+            <a:off x="4291584" y="1371600"/>
+            <a:ext cx="3605784" cy="1664208"/>
           </a:xfrm>
           <a:prstGeom prst="roundRect">
             <a:avLst>
@@ -3039,7 +3039,7 @@
         </p:nvSpPr>
         <p:spPr>
           <a:xfrm>
-            <a:off x="4654296" y="1536192"/>
+            <a:off x="4474464" y="1536192"/>
             <a:ext cx="384048" cy="384048"/>
           </a:xfrm>
           <a:prstGeom prst="ellipse">
@@ -3067,7 +3067,7 @@
         </p:blipFill>
         <p:spPr>
           <a:xfrm>
-            <a:off x="4736592" y="1618488"/>
+            <a:off x="4556760" y="1618488"/>
             <a:ext cx="219456" cy="219456"/>
           </a:xfrm>
           <a:prstGeom prst="rect">
@@ -3083,8 +3083,8 @@
         </p:nvSpPr>
         <p:spPr>
           <a:xfrm>
-            <a:off x="5129784" y="1536192"/>
-            <a:ext cx="2926080" cy="384048"/>
+            <a:off x="4949952" y="1536192"/>
+            <a:ext cx="2764536" cy="384048"/>
           </a:xfrm>
           <a:prstGeom prst="rect">
             <a:avLst/>
@@ -3122,8 +3122,8 @@
         </p:nvSpPr>
         <p:spPr>
           <a:xfrm>
-            <a:off x="4654296" y="1993392"/>
-            <a:ext cx="3419856" cy="932688"/>
+            <a:off x="4474464" y="1993392"/>
+            <a:ext cx="3240024" cy="932688"/>
           </a:xfrm>
           <a:prstGeom prst="rect">
             <a:avLst/>
@@ -3161,8 +3161,8 @@
         </p:nvSpPr>
         <p:spPr>
           <a:xfrm>
-            <a:off x="8439912" y="1371600"/>
-            <a:ext cx="3785616" cy="1664208"/>
+            <a:off x="8080248" y="1371600"/>
+            <a:ext cx="3605784" cy="1664208"/>
           </a:xfrm>
           <a:prstGeom prst="roundRect">
             <a:avLst>
@@ -3195,7 +3195,7 @@
         </p:nvSpPr>
         <p:spPr>
           <a:xfrm>
-            <a:off x="8622792" y="1536192"/>
+            <a:off x="8263128" y="1536192"/>
             <a:ext cx="384048" cy="384048"/>
           </a:xfrm>
           <a:prstGeom prst="ellipse">
@@ -3223,7 +3223,7 @@
         </p:blipFill>
         <p:spPr>
           <a:xfrm>
-            <a:off x="8705088" y="1618488"/>
+            <a:off x="8345424" y="1618488"/>
             <a:ext cx="219456" cy="219456"/>
           </a:xfrm>
           <a:prstGeom prst="rect">
@@ -3239,8 +3239,8 @@
         </p:nvSpPr>
         <p:spPr>
           <a:xfrm>
-            <a:off x="9098280" y="1536192"/>
-            <a:ext cx="2926080" cy="384048"/>
+            <a:off x="8738616" y="1536192"/>
+            <a:ext cx="2764536" cy="384048"/>
           </a:xfrm>
           <a:prstGeom prst="rect">
             <a:avLst/>
@@ -3278,8 +3278,8 @@
         </p:nvSpPr>
         <p:spPr>
           <a:xfrm>
-            <a:off x="8622792" y="1993392"/>
-            <a:ext cx="3419856" cy="932688"/>
+            <a:off x="8263128" y="1993392"/>
+            <a:ext cx="3240024" cy="932688"/>
           </a:xfrm>
           <a:prstGeom prst="rect">
             <a:avLst/>
@@ -3318,7 +3318,7 @@
         <p:spPr>
           <a:xfrm>
             <a:off x="502920" y="3200400"/>
-            <a:ext cx="3785616" cy="1664208"/>
+            <a:ext cx="3605784" cy="1664208"/>
           </a:xfrm>
           <a:prstGeom prst="roundRect">
             <a:avLst>
@@ -3396,7 +3396,7 @@
         <p:spPr>
           <a:xfrm>
             <a:off x="1161288" y="3364992"/>
-            <a:ext cx="2926080" cy="384048"/>
+            <a:ext cx="2764536" cy="384048"/>
           </a:xfrm>
           <a:prstGeom prst="rect">
             <a:avLst/>
@@ -3435,7 +3435,7 @@
         <p:spPr>
           <a:xfrm>
             <a:off x="685800" y="3822192"/>
-            <a:ext cx="3419856" cy="932688"/>
+            <a:ext cx="3240024" cy="932688"/>
           </a:xfrm>
           <a:prstGeom prst="rect">
             <a:avLst/>
@@ -3473,8 +3473,8 @@
         </p:nvSpPr>
         <p:spPr>
           <a:xfrm>
-            <a:off x="4471416" y="3200400"/>
-            <a:ext cx="3785616" cy="1664208"/>
+            <a:off x="4291584" y="3200400"/>
+            <a:ext cx="3605784" cy="1664208"/>
           </a:xfrm>
           <a:prstGeom prst="roundRect">
             <a:avLst>
@@ -3507,7 +3507,7 @@
         </p:nvSpPr>
         <p:spPr>
           <a:xfrm>
-            <a:off x="4654296" y="3364992"/>
+            <a:off x="4474464" y="3364992"/>
             <a:ext cx="384048" cy="384048"/>
           </a:xfrm>
           <a:prstGeom prst="ellipse">
@@ -3535,7 +3535,7 @@
         </p:blipFill>
         <p:spPr>
           <a:xfrm>
-            <a:off x="4736592" y="3447288"/>
+            <a:off x="4556760" y="3447288"/>
             <a:ext cx="219456" cy="219456"/>
           </a:xfrm>
           <a:prstGeom prst="rect">
@@ -3551,8 +3551,8 @@
         </p:nvSpPr>
         <p:spPr>
           <a:xfrm>
-            <a:off x="5129784" y="3364992"/>
-            <a:ext cx="2926080" cy="384048"/>
+            <a:off x="4949952" y="3364992"/>
+            <a:ext cx="2764536" cy="384048"/>
           </a:xfrm>
           <a:prstGeom prst="rect">
             <a:avLst/>
@@ -3590,8 +3590,8 @@
         </p:nvSpPr>
         <p:spPr>
           <a:xfrm>
-            <a:off x="4654296" y="3822192"/>
-            <a:ext cx="3419856" cy="932688"/>
+            <a:off x="4474464" y="3822192"/>
+            <a:ext cx="3240024" cy="932688"/>
           </a:xfrm>
           <a:prstGeom prst="rect">
             <a:avLst/>
@@ -3629,8 +3629,8 @@
         </p:nvSpPr>
         <p:spPr>
           <a:xfrm>
-            <a:off x="8439912" y="3200400"/>
-            <a:ext cx="3785616" cy="1664208"/>
+            <a:off x="8080248" y="3200400"/>
+            <a:ext cx="3605784" cy="1664208"/>
           </a:xfrm>
           <a:prstGeom prst="roundRect">
             <a:avLst>
@@ -3663,7 +3663,7 @@
         </p:nvSpPr>
         <p:spPr>
           <a:xfrm>
-            <a:off x="8622792" y="3364992"/>
+            <a:off x="8263128" y="3364992"/>
             <a:ext cx="384048" cy="384048"/>
           </a:xfrm>
           <a:prstGeom prst="ellipse">
@@ -3691,7 +3691,7 @@
         </p:blipFill>
         <p:spPr>
           <a:xfrm>
-            <a:off x="8705088" y="3447288"/>
+            <a:off x="8345424" y="3447288"/>
             <a:ext cx="219456" cy="219456"/>
           </a:xfrm>
           <a:prstGeom prst="rect">
@@ -3707,8 +3707,8 @@
         </p:nvSpPr>
         <p:spPr>
           <a:xfrm>
-            <a:off x="9098280" y="3364992"/>
-            <a:ext cx="2926080" cy="384048"/>
+            <a:off x="8738616" y="3364992"/>
+            <a:ext cx="2764536" cy="384048"/>
           </a:xfrm>
           <a:prstGeom prst="rect">
             <a:avLst/>
@@ -3746,8 +3746,8 @@
         </p:nvSpPr>
         <p:spPr>
           <a:xfrm>
-            <a:off x="8622792" y="3822192"/>
-            <a:ext cx="3419856" cy="932688"/>
+            <a:off x="8263128" y="3822192"/>
+            <a:ext cx="3240024" cy="932688"/>
           </a:xfrm>
           <a:prstGeom prst="rect">
             <a:avLst/>
@@ -3987,7 +3987,7 @@
                 <a:ea typeface="Arial" pitchFamily="34" charset="-122"/>
                 <a:cs typeface="Arial" pitchFamily="34" charset="-120"/>
               </a:rPr>
-              <a:t>O diagnóstico: oito perguntas que a sua operação precisa responder</a:t>
+              <a:t>O diagnóstico: oito perguntas objetivas</a:t>
             </a:r>
             <a:endParaRPr lang="en-US" sz="2800" dirty="0"/>
           </a:p>
@@ -4026,7 +4026,7 @@
                 <a:ea typeface="Arial" pitchFamily="34" charset="-122"/>
                 <a:cs typeface="Arial" pitchFamily="34" charset="-120"/>
               </a:rPr>
-              <a:t>A resposta que não vem acompanhada de evidência é, por definição, a lacuna.</a:t>
+              <a:t>São as perguntas que a sua operação precisa responder. A resposta que não vem acompanhada de evidência é, por definição, a lacuna.</a:t>
             </a:r>
             <a:endParaRPr lang="en-US" sz="1500" dirty="0"/>
           </a:p>
@@ -4041,7 +4041,7 @@
         <p:spPr>
           <a:xfrm>
             <a:off x="502920" y="1371600"/>
-            <a:ext cx="2734056" cy="1417320"/>
+            <a:ext cx="2658618" cy="1417320"/>
           </a:xfrm>
           <a:prstGeom prst="roundRect">
             <a:avLst>
@@ -4074,8 +4074,8 @@
         </p:nvSpPr>
         <p:spPr>
           <a:xfrm>
-            <a:off x="667512" y="1481328"/>
-            <a:ext cx="365760" cy="274320"/>
+            <a:off x="649224" y="1481328"/>
+            <a:ext cx="310896" cy="274320"/>
           </a:xfrm>
           <a:prstGeom prst="rect">
             <a:avLst/>
@@ -4113,8 +4113,8 @@
         </p:nvSpPr>
         <p:spPr>
           <a:xfrm>
-            <a:off x="960120" y="1481328"/>
-            <a:ext cx="2148840" cy="310896"/>
+            <a:off x="923544" y="1481328"/>
+            <a:ext cx="2091690" cy="310896"/>
           </a:xfrm>
           <a:prstGeom prst="rect">
             <a:avLst/>
@@ -4130,7 +4130,7 @@
               <a:buNone/>
             </a:pPr>
             <a:r>
-              <a:rPr lang="en-US" sz="1250" b="1" dirty="0">
+              <a:rPr lang="en-US" sz="1200" b="1" dirty="0">
                 <a:solidFill>
                   <a:srgbClr val="69103F"/>
                 </a:solidFill>
@@ -4140,7 +4140,7 @@
               </a:rPr>
               <a:t>Controle de pagamentos</a:t>
             </a:r>
-            <a:endParaRPr lang="en-US" sz="1250" dirty="0"/>
+            <a:endParaRPr lang="en-US" sz="1200" dirty="0"/>
           </a:p>
         </p:txBody>
       </p:sp>
@@ -4152,8 +4152,8 @@
         </p:nvSpPr>
         <p:spPr>
           <a:xfrm>
-            <a:off x="667512" y="1847088"/>
-            <a:ext cx="2404872" cy="822960"/>
+            <a:off x="649224" y="1847088"/>
+            <a:ext cx="2366010" cy="822960"/>
           </a:xfrm>
           <a:prstGeom prst="rect">
             <a:avLst/>
@@ -4169,7 +4169,7 @@
               <a:buNone/>
             </a:pPr>
             <a:r>
-              <a:rPr lang="en-US" sz="1150" i="1" dirty="0">
+              <a:rPr lang="en-US" sz="1100" i="1" dirty="0">
                 <a:solidFill>
                   <a:srgbClr val="33373D"/>
                 </a:solidFill>
@@ -4179,7 +4179,7 @@
               </a:rPr>
               <a:t>"Quem aprova o quê, com que alçada e que trava?"</a:t>
             </a:r>
-            <a:endParaRPr lang="en-US" sz="1150" dirty="0"/>
+            <a:endParaRPr lang="en-US" sz="1100" dirty="0"/>
           </a:p>
         </p:txBody>
       </p:sp>
@@ -4191,8 +4191,8 @@
         </p:nvSpPr>
         <p:spPr>
           <a:xfrm>
-            <a:off x="3419856" y="1371600"/>
-            <a:ext cx="2734056" cy="1417320"/>
+            <a:off x="3344418" y="1371600"/>
+            <a:ext cx="2658618" cy="1417320"/>
           </a:xfrm>
           <a:prstGeom prst="roundRect">
             <a:avLst>
@@ -4225,8 +4225,8 @@
         </p:nvSpPr>
         <p:spPr>
           <a:xfrm>
-            <a:off x="3584448" y="1481328"/>
-            <a:ext cx="365760" cy="274320"/>
+            <a:off x="3490722" y="1481328"/>
+            <a:ext cx="310896" cy="274320"/>
           </a:xfrm>
           <a:prstGeom prst="rect">
             <a:avLst/>
@@ -4264,8 +4264,8 @@
         </p:nvSpPr>
         <p:spPr>
           <a:xfrm>
-            <a:off x="3877056" y="1481328"/>
-            <a:ext cx="2148840" cy="310896"/>
+            <a:off x="3765042" y="1481328"/>
+            <a:ext cx="2091690" cy="310896"/>
           </a:xfrm>
           <a:prstGeom prst="rect">
             <a:avLst/>
@@ -4281,7 +4281,7 @@
               <a:buNone/>
             </a:pPr>
             <a:r>
-              <a:rPr lang="en-US" sz="1250" b="1" dirty="0">
+              <a:rPr lang="en-US" sz="1200" b="1" dirty="0">
                 <a:solidFill>
                   <a:srgbClr val="69103F"/>
                 </a:solidFill>
@@ -4291,7 +4291,7 @@
               </a:rPr>
               <a:t>Determinações judiciais</a:t>
             </a:r>
-            <a:endParaRPr lang="en-US" sz="1250" dirty="0"/>
+            <a:endParaRPr lang="en-US" sz="1200" dirty="0"/>
           </a:p>
         </p:txBody>
       </p:sp>
@@ -4303,8 +4303,8 @@
         </p:nvSpPr>
         <p:spPr>
           <a:xfrm>
-            <a:off x="3584448" y="1847088"/>
-            <a:ext cx="2404872" cy="822960"/>
+            <a:off x="3490722" y="1847088"/>
+            <a:ext cx="2366010" cy="822960"/>
           </a:xfrm>
           <a:prstGeom prst="rect">
             <a:avLst/>
@@ -4320,7 +4320,7 @@
               <a:buNone/>
             </a:pPr>
             <a:r>
-              <a:rPr lang="en-US" sz="1150" i="1" dirty="0">
+              <a:rPr lang="en-US" sz="1100" i="1" dirty="0">
                 <a:solidFill>
                   <a:srgbClr val="33373D"/>
                 </a:solidFill>
@@ -4330,7 +4330,7 @@
               </a:rPr>
               <a:t>"Quem recebe a ordem, quem cumpre e onde está a prova?"</a:t>
             </a:r>
-            <a:endParaRPr lang="en-US" sz="1150" dirty="0"/>
+            <a:endParaRPr lang="en-US" sz="1100" dirty="0"/>
           </a:p>
         </p:txBody>
       </p:sp>
@@ -4342,8 +4342,8 @@
         </p:nvSpPr>
         <p:spPr>
           <a:xfrm>
-            <a:off x="6336792" y="1371600"/>
-            <a:ext cx="2734056" cy="1417320"/>
+            <a:off x="6185916" y="1371600"/>
+            <a:ext cx="2658618" cy="1417320"/>
           </a:xfrm>
           <a:prstGeom prst="roundRect">
             <a:avLst>
@@ -4376,8 +4376,8 @@
         </p:nvSpPr>
         <p:spPr>
           <a:xfrm>
-            <a:off x="6501384" y="1481328"/>
-            <a:ext cx="365760" cy="274320"/>
+            <a:off x="6332220" y="1481328"/>
+            <a:ext cx="310896" cy="274320"/>
           </a:xfrm>
           <a:prstGeom prst="rect">
             <a:avLst/>
@@ -4415,8 +4415,8 @@
         </p:nvSpPr>
         <p:spPr>
           <a:xfrm>
-            <a:off x="6793992" y="1481328"/>
-            <a:ext cx="2148840" cy="310896"/>
+            <a:off x="6606540" y="1481328"/>
+            <a:ext cx="2091690" cy="310896"/>
           </a:xfrm>
           <a:prstGeom prst="rect">
             <a:avLst/>
@@ -4432,7 +4432,7 @@
               <a:buNone/>
             </a:pPr>
             <a:r>
-              <a:rPr lang="en-US" sz="1250" b="1" dirty="0">
+              <a:rPr lang="en-US" sz="1200" b="1" dirty="0">
                 <a:solidFill>
                   <a:srgbClr val="69103F"/>
                 </a:solidFill>
@@ -4442,7 +4442,7 @@
               </a:rPr>
               <a:t>Onboarding e KYC</a:t>
             </a:r>
-            <a:endParaRPr lang="en-US" sz="1250" dirty="0"/>
+            <a:endParaRPr lang="en-US" sz="1200" dirty="0"/>
           </a:p>
         </p:txBody>
       </p:sp>
@@ -4454,8 +4454,8 @@
         </p:nvSpPr>
         <p:spPr>
           <a:xfrm>
-            <a:off x="6501384" y="1847088"/>
-            <a:ext cx="2404872" cy="822960"/>
+            <a:off x="6332220" y="1847088"/>
+            <a:ext cx="2366010" cy="822960"/>
           </a:xfrm>
           <a:prstGeom prst="rect">
             <a:avLst/>
@@ -4471,7 +4471,7 @@
               <a:buNone/>
             </a:pPr>
             <a:r>
-              <a:rPr lang="en-US" sz="1150" i="1" dirty="0">
+              <a:rPr lang="en-US" sz="1100" i="1" dirty="0">
                 <a:solidFill>
                   <a:srgbClr val="33373D"/>
                 </a:solidFill>
@@ -4481,7 +4481,7 @@
               </a:rPr>
               <a:t>"Como se verifica quem abre a conta — e quando se recusa?"</a:t>
             </a:r>
-            <a:endParaRPr lang="en-US" sz="1150" dirty="0"/>
+            <a:endParaRPr lang="en-US" sz="1100" dirty="0"/>
           </a:p>
         </p:txBody>
       </p:sp>
@@ -4493,8 +4493,8 @@
         </p:nvSpPr>
         <p:spPr>
           <a:xfrm>
-            <a:off x="9253728" y="1371600"/>
-            <a:ext cx="2734056" cy="1417320"/>
+            <a:off x="9027414" y="1371600"/>
+            <a:ext cx="2658618" cy="1417320"/>
           </a:xfrm>
           <a:prstGeom prst="roundRect">
             <a:avLst>
@@ -4527,8 +4527,8 @@
         </p:nvSpPr>
         <p:spPr>
           <a:xfrm>
-            <a:off x="9418320" y="1481328"/>
-            <a:ext cx="365760" cy="274320"/>
+            <a:off x="9173718" y="1481328"/>
+            <a:ext cx="310896" cy="274320"/>
           </a:xfrm>
           <a:prstGeom prst="rect">
             <a:avLst/>
@@ -4566,8 +4566,8 @@
         </p:nvSpPr>
         <p:spPr>
           <a:xfrm>
-            <a:off x="9710928" y="1481328"/>
-            <a:ext cx="2148840" cy="310896"/>
+            <a:off x="9448038" y="1481328"/>
+            <a:ext cx="2091690" cy="310896"/>
           </a:xfrm>
           <a:prstGeom prst="rect">
             <a:avLst/>
@@ -4583,7 +4583,7 @@
               <a:buNone/>
             </a:pPr>
             <a:r>
-              <a:rPr lang="en-US" sz="1250" b="1" dirty="0">
+              <a:rPr lang="en-US" sz="1200" b="1" dirty="0">
                 <a:solidFill>
                   <a:srgbClr val="69103F"/>
                 </a:solidFill>
@@ -4593,7 +4593,7 @@
               </a:rPr>
               <a:t>Detecção e acionamento</a:t>
             </a:r>
-            <a:endParaRPr lang="en-US" sz="1250" dirty="0"/>
+            <a:endParaRPr lang="en-US" sz="1200" dirty="0"/>
           </a:p>
         </p:txBody>
       </p:sp>
@@ -4605,8 +4605,8 @@
         </p:nvSpPr>
         <p:spPr>
           <a:xfrm>
-            <a:off x="9418320" y="1847088"/>
-            <a:ext cx="2404872" cy="822960"/>
+            <a:off x="9173718" y="1847088"/>
+            <a:ext cx="2366010" cy="822960"/>
           </a:xfrm>
           <a:prstGeom prst="rect">
             <a:avLst/>
@@ -4622,7 +4622,7 @@
               <a:buNone/>
             </a:pPr>
             <a:r>
-              <a:rPr lang="en-US" sz="1150" i="1" dirty="0">
+              <a:rPr lang="en-US" sz="1100" i="1" dirty="0">
                 <a:solidFill>
                   <a:srgbClr val="33373D"/>
                 </a:solidFill>
@@ -4632,7 +4632,7 @@
               </a:rPr>
               <a:t>"Às 3h de domingo, quem forma a fundada suspeita?"</a:t>
             </a:r>
-            <a:endParaRPr lang="en-US" sz="1150" dirty="0"/>
+            <a:endParaRPr lang="en-US" sz="1100" dirty="0"/>
           </a:p>
         </p:txBody>
       </p:sp>
@@ -4645,7 +4645,7 @@
         <p:spPr>
           <a:xfrm>
             <a:off x="502920" y="2944368"/>
-            <a:ext cx="2734056" cy="1417320"/>
+            <a:ext cx="2658618" cy="1417320"/>
           </a:xfrm>
           <a:prstGeom prst="roundRect">
             <a:avLst>
@@ -4678,8 +4678,8 @@
         </p:nvSpPr>
         <p:spPr>
           <a:xfrm>
-            <a:off x="667512" y="3054096"/>
-            <a:ext cx="365760" cy="274320"/>
+            <a:off x="649224" y="3054096"/>
+            <a:ext cx="310896" cy="274320"/>
           </a:xfrm>
           <a:prstGeom prst="rect">
             <a:avLst/>
@@ -4717,8 +4717,8 @@
         </p:nvSpPr>
         <p:spPr>
           <a:xfrm>
-            <a:off x="960120" y="3054096"/>
-            <a:ext cx="2148840" cy="310896"/>
+            <a:off x="923544" y="3054096"/>
+            <a:ext cx="2091690" cy="310896"/>
           </a:xfrm>
           <a:prstGeom prst="rect">
             <a:avLst/>
@@ -4734,7 +4734,7 @@
               <a:buNone/>
             </a:pPr>
             <a:r>
-              <a:rPr lang="en-US" sz="1250" b="1" dirty="0">
+              <a:rPr lang="en-US" sz="1200" b="1" dirty="0">
                 <a:solidFill>
                   <a:srgbClr val="69103F"/>
                 </a:solidFill>
@@ -4744,7 +4744,7 @@
               </a:rPr>
               <a:t>Fornecedores e PSTI</a:t>
             </a:r>
-            <a:endParaRPr lang="en-US" sz="1250" dirty="0"/>
+            <a:endParaRPr lang="en-US" sz="1200" dirty="0"/>
           </a:p>
         </p:txBody>
       </p:sp>
@@ -4756,8 +4756,8 @@
         </p:nvSpPr>
         <p:spPr>
           <a:xfrm>
-            <a:off x="667512" y="3419856"/>
-            <a:ext cx="2404872" cy="822960"/>
+            <a:off x="649224" y="3419856"/>
+            <a:ext cx="2366010" cy="822960"/>
           </a:xfrm>
           <a:prstGeom prst="rect">
             <a:avLst/>
@@ -4773,7 +4773,7 @@
               <a:buNone/>
             </a:pPr>
             <a:r>
-              <a:rPr lang="en-US" sz="1150" i="1" dirty="0">
+              <a:rPr lang="en-US" sz="1100" i="1" dirty="0">
                 <a:solidFill>
                   <a:srgbClr val="33373D"/>
                 </a:solidFill>
@@ -4783,7 +4783,7 @@
               </a:rPr>
               <a:t>"Quem, fora de casa, tem a chave da sua casa?"</a:t>
             </a:r>
-            <a:endParaRPr lang="en-US" sz="1150" dirty="0"/>
+            <a:endParaRPr lang="en-US" sz="1100" dirty="0"/>
           </a:p>
         </p:txBody>
       </p:sp>
@@ -4795,8 +4795,8 @@
         </p:nvSpPr>
         <p:spPr>
           <a:xfrm>
-            <a:off x="3419856" y="2944368"/>
-            <a:ext cx="2734056" cy="1417320"/>
+            <a:off x="3344418" y="2944368"/>
+            <a:ext cx="2658618" cy="1417320"/>
           </a:xfrm>
           <a:prstGeom prst="roundRect">
             <a:avLst>
@@ -4829,8 +4829,8 @@
         </p:nvSpPr>
         <p:spPr>
           <a:xfrm>
-            <a:off x="3584448" y="3054096"/>
-            <a:ext cx="365760" cy="274320"/>
+            <a:off x="3490722" y="3054096"/>
+            <a:ext cx="310896" cy="274320"/>
           </a:xfrm>
           <a:prstGeom prst="rect">
             <a:avLst/>
@@ -4868,8 +4868,8 @@
         </p:nvSpPr>
         <p:spPr>
           <a:xfrm>
-            <a:off x="3877056" y="3054096"/>
-            <a:ext cx="2148840" cy="310896"/>
+            <a:off x="3765042" y="3054096"/>
+            <a:ext cx="2091690" cy="310896"/>
           </a:xfrm>
           <a:prstGeom prst="rect">
             <a:avLst/>
@@ -4885,7 +4885,7 @@
               <a:buNone/>
             </a:pPr>
             <a:r>
-              <a:rPr lang="en-US" sz="1250" b="1" dirty="0">
+              <a:rPr lang="en-US" sz="1200" b="1" dirty="0">
                 <a:solidFill>
                   <a:srgbClr val="69103F"/>
                 </a:solidFill>
@@ -4895,7 +4895,7 @@
               </a:rPr>
               <a:t>Incidente e dados pessoais</a:t>
             </a:r>
-            <a:endParaRPr lang="en-US" sz="1250" dirty="0"/>
+            <a:endParaRPr lang="en-US" sz="1200" dirty="0"/>
           </a:p>
         </p:txBody>
       </p:sp>
@@ -4907,8 +4907,8 @@
         </p:nvSpPr>
         <p:spPr>
           <a:xfrm>
-            <a:off x="3584448" y="3419856"/>
-            <a:ext cx="2404872" cy="822960"/>
+            <a:off x="3490722" y="3419856"/>
+            <a:ext cx="2366010" cy="822960"/>
           </a:xfrm>
           <a:prstGeom prst="rect">
             <a:avLst/>
@@ -4924,7 +4924,7 @@
               <a:buNone/>
             </a:pPr>
             <a:r>
-              <a:rPr lang="en-US" sz="1150" i="1" dirty="0">
+              <a:rPr lang="en-US" sz="1100" i="1" dirty="0">
                 <a:solidFill>
                   <a:srgbClr val="33373D"/>
                 </a:solidFill>
@@ -4934,7 +4934,7 @@
               </a:rPr>
               <a:t>"Que horas você soube — e onde isso está escrito?"</a:t>
             </a:r>
-            <a:endParaRPr lang="en-US" sz="1150" dirty="0"/>
+            <a:endParaRPr lang="en-US" sz="1100" dirty="0"/>
           </a:p>
         </p:txBody>
       </p:sp>
@@ -4946,8 +4946,8 @@
         </p:nvSpPr>
         <p:spPr>
           <a:xfrm>
-            <a:off x="6336792" y="2944368"/>
-            <a:ext cx="2734056" cy="1417320"/>
+            <a:off x="6185916" y="2944368"/>
+            <a:ext cx="2658618" cy="1417320"/>
           </a:xfrm>
           <a:prstGeom prst="roundRect">
             <a:avLst>
@@ -4980,8 +4980,8 @@
         </p:nvSpPr>
         <p:spPr>
           <a:xfrm>
-            <a:off x="6501384" y="3054096"/>
-            <a:ext cx="365760" cy="274320"/>
+            <a:off x="6332220" y="3054096"/>
+            <a:ext cx="310896" cy="274320"/>
           </a:xfrm>
           <a:prstGeom prst="rect">
             <a:avLst/>
@@ -5019,8 +5019,8 @@
         </p:nvSpPr>
         <p:spPr>
           <a:xfrm>
-            <a:off x="6793992" y="3054096"/>
-            <a:ext cx="2148840" cy="310896"/>
+            <a:off x="6606540" y="3054096"/>
+            <a:ext cx="2091690" cy="310896"/>
           </a:xfrm>
           <a:prstGeom prst="rect">
             <a:avLst/>
@@ -5036,7 +5036,7 @@
               <a:buNone/>
             </a:pPr>
             <a:r>
-              <a:rPr lang="en-US" sz="1250" b="1" dirty="0">
+              <a:rPr lang="en-US" sz="1200" b="1" dirty="0">
                 <a:solidFill>
                   <a:srgbClr val="69103F"/>
                 </a:solidFill>
@@ -5046,7 +5046,7 @@
               </a:rPr>
               <a:t>Prova e cadeia de custódia</a:t>
             </a:r>
-            <a:endParaRPr lang="en-US" sz="1250" dirty="0"/>
+            <a:endParaRPr lang="en-US" sz="1200" dirty="0"/>
           </a:p>
         </p:txBody>
       </p:sp>
@@ -5058,8 +5058,8 @@
         </p:nvSpPr>
         <p:spPr>
           <a:xfrm>
-            <a:off x="6501384" y="3419856"/>
-            <a:ext cx="2404872" cy="822960"/>
+            <a:off x="6332220" y="3419856"/>
+            <a:ext cx="2366010" cy="822960"/>
           </a:xfrm>
           <a:prstGeom prst="rect">
             <a:avLst/>
@@ -5075,7 +5075,7 @@
               <a:buNone/>
             </a:pPr>
             <a:r>
-              <a:rPr lang="en-US" sz="1150" i="1" dirty="0">
+              <a:rPr lang="en-US" sz="1100" i="1" dirty="0">
                 <a:solidFill>
                   <a:srgbClr val="33373D"/>
                 </a:solidFill>
@@ -5085,7 +5085,7 @@
               </a:rPr>
               <a:t>"O que você preserva antes de corrigir?"</a:t>
             </a:r>
-            <a:endParaRPr lang="en-US" sz="1150" dirty="0"/>
+            <a:endParaRPr lang="en-US" sz="1100" dirty="0"/>
           </a:p>
         </p:txBody>
       </p:sp>
@@ -5097,8 +5097,8 @@
         </p:nvSpPr>
         <p:spPr>
           <a:xfrm>
-            <a:off x="9253728" y="2944368"/>
-            <a:ext cx="2734056" cy="1417320"/>
+            <a:off x="9027414" y="2944368"/>
+            <a:ext cx="2658618" cy="1417320"/>
           </a:xfrm>
           <a:prstGeom prst="roundRect">
             <a:avLst>
@@ -5131,8 +5131,8 @@
         </p:nvSpPr>
         <p:spPr>
           <a:xfrm>
-            <a:off x="9418320" y="3054096"/>
-            <a:ext cx="365760" cy="274320"/>
+            <a:off x="9173718" y="3054096"/>
+            <a:ext cx="310896" cy="274320"/>
           </a:xfrm>
           <a:prstGeom prst="rect">
             <a:avLst/>
@@ -5170,8 +5170,8 @@
         </p:nvSpPr>
         <p:spPr>
           <a:xfrm>
-            <a:off x="9710928" y="3054096"/>
-            <a:ext cx="2148840" cy="310896"/>
+            <a:off x="9448038" y="3054096"/>
+            <a:ext cx="2091690" cy="310896"/>
           </a:xfrm>
           <a:prstGeom prst="rect">
             <a:avLst/>
@@ -5187,7 +5187,7 @@
               <a:buNone/>
             </a:pPr>
             <a:r>
-              <a:rPr lang="en-US" sz="1250" b="1" dirty="0">
+              <a:rPr lang="en-US" sz="1200" b="1" dirty="0">
                 <a:solidFill>
                   <a:srgbClr val="69103F"/>
                 </a:solidFill>
@@ -5197,7 +5197,7 @@
               </a:rPr>
               <a:t>Governança de crise</a:t>
             </a:r>
-            <a:endParaRPr lang="en-US" sz="1250" dirty="0"/>
+            <a:endParaRPr lang="en-US" sz="1200" dirty="0"/>
           </a:p>
         </p:txBody>
       </p:sp>
@@ -5209,8 +5209,8 @@
         </p:nvSpPr>
         <p:spPr>
           <a:xfrm>
-            <a:off x="9418320" y="3419856"/>
-            <a:ext cx="2404872" cy="822960"/>
+            <a:off x="9173718" y="3419856"/>
+            <a:ext cx="2366010" cy="822960"/>
           </a:xfrm>
           <a:prstGeom prst="rect">
             <a:avLst/>
@@ -5226,7 +5226,7 @@
               <a:buNone/>
             </a:pPr>
             <a:r>
-              <a:rPr lang="en-US" sz="1150" i="1" dirty="0">
+              <a:rPr lang="en-US" sz="1100" i="1" dirty="0">
                 <a:solidFill>
                   <a:srgbClr val="33373D"/>
                 </a:solidFill>
@@ -5236,7 +5236,7 @@
               </a:rPr>
               <a:t>"Qual é o seu critério escrito do que é crise?"</a:t>
             </a:r>
-            <a:endParaRPr lang="en-US" sz="1150" dirty="0"/>
+            <a:endParaRPr lang="en-US" sz="1100" dirty="0"/>
           </a:p>
         </p:txBody>
       </p:sp>
@@ -5543,7 +5543,7 @@
         <p:spPr>
           <a:xfrm>
             <a:off x="502920" y="1371600"/>
-            <a:ext cx="5614416" cy="914400"/>
+            <a:ext cx="5500116" cy="914400"/>
           </a:xfrm>
           <a:prstGeom prst="roundRect">
             <a:avLst>
@@ -5577,7 +5577,7 @@
         <p:spPr>
           <a:xfrm>
             <a:off x="685800" y="1463040"/>
-            <a:ext cx="5248656" cy="749808"/>
+            <a:ext cx="5134356" cy="749808"/>
           </a:xfrm>
           <a:prstGeom prst="rect">
             <a:avLst/>
@@ -5630,8 +5630,8 @@
         </p:nvSpPr>
         <p:spPr>
           <a:xfrm>
-            <a:off x="6300216" y="1371600"/>
-            <a:ext cx="5614416" cy="914400"/>
+            <a:off x="6185916" y="1371600"/>
+            <a:ext cx="5500116" cy="914400"/>
           </a:xfrm>
           <a:prstGeom prst="roundRect">
             <a:avLst>
@@ -5664,8 +5664,8 @@
         </p:nvSpPr>
         <p:spPr>
           <a:xfrm>
-            <a:off x="6483096" y="1463040"/>
-            <a:ext cx="5248656" cy="749808"/>
+            <a:off x="6368796" y="1463040"/>
+            <a:ext cx="5134356" cy="749808"/>
           </a:xfrm>
           <a:prstGeom prst="rect">
             <a:avLst/>
@@ -5719,7 +5719,7 @@
         <p:spPr>
           <a:xfrm>
             <a:off x="502920" y="2404872"/>
-            <a:ext cx="5614416" cy="914400"/>
+            <a:ext cx="5500116" cy="914400"/>
           </a:xfrm>
           <a:prstGeom prst="roundRect">
             <a:avLst>
@@ -5753,7 +5753,7 @@
         <p:spPr>
           <a:xfrm>
             <a:off x="685800" y="2496312"/>
-            <a:ext cx="5248656" cy="749808"/>
+            <a:ext cx="5134356" cy="749808"/>
           </a:xfrm>
           <a:prstGeom prst="rect">
             <a:avLst/>
@@ -5806,8 +5806,8 @@
         </p:nvSpPr>
         <p:spPr>
           <a:xfrm>
-            <a:off x="6300216" y="2404872"/>
-            <a:ext cx="5614416" cy="914400"/>
+            <a:off x="6185916" y="2404872"/>
+            <a:ext cx="5500116" cy="914400"/>
           </a:xfrm>
           <a:prstGeom prst="roundRect">
             <a:avLst>
@@ -5840,8 +5840,8 @@
         </p:nvSpPr>
         <p:spPr>
           <a:xfrm>
-            <a:off x="6483096" y="2496312"/>
-            <a:ext cx="5248656" cy="749808"/>
+            <a:off x="6368796" y="2496312"/>
+            <a:ext cx="5134356" cy="749808"/>
           </a:xfrm>
           <a:prstGeom prst="rect">
             <a:avLst/>
@@ -5895,7 +5895,7 @@
         <p:spPr>
           <a:xfrm>
             <a:off x="502920" y="3438144"/>
-            <a:ext cx="5614416" cy="914400"/>
+            <a:ext cx="5500116" cy="914400"/>
           </a:xfrm>
           <a:prstGeom prst="roundRect">
             <a:avLst>
@@ -5929,7 +5929,7 @@
         <p:spPr>
           <a:xfrm>
             <a:off x="685800" y="3529584"/>
-            <a:ext cx="5248656" cy="749808"/>
+            <a:ext cx="5134356" cy="749808"/>
           </a:xfrm>
           <a:prstGeom prst="rect">
             <a:avLst/>
@@ -5982,8 +5982,8 @@
         </p:nvSpPr>
         <p:spPr>
           <a:xfrm>
-            <a:off x="6300216" y="3438144"/>
-            <a:ext cx="5614416" cy="914400"/>
+            <a:off x="6185916" y="3438144"/>
+            <a:ext cx="5500116" cy="914400"/>
           </a:xfrm>
           <a:prstGeom prst="roundRect">
             <a:avLst>
@@ -6016,8 +6016,8 @@
         </p:nvSpPr>
         <p:spPr>
           <a:xfrm>
-            <a:off x="6483096" y="3529584"/>
-            <a:ext cx="5248656" cy="749808"/>
+            <a:off x="6368796" y="3529584"/>
+            <a:ext cx="5134356" cy="749808"/>
           </a:xfrm>
           <a:prstGeom prst="rect">
             <a:avLst/>
@@ -6071,7 +6071,7 @@
         <p:spPr>
           <a:xfrm>
             <a:off x="502920" y="4471416"/>
-            <a:ext cx="5614416" cy="914400"/>
+            <a:ext cx="5500116" cy="914400"/>
           </a:xfrm>
           <a:prstGeom prst="roundRect">
             <a:avLst>
@@ -6105,7 +6105,7 @@
         <p:spPr>
           <a:xfrm>
             <a:off x="685800" y="4562856"/>
-            <a:ext cx="5248656" cy="749808"/>
+            <a:ext cx="5134356" cy="749808"/>
           </a:xfrm>
           <a:prstGeom prst="rect">
             <a:avLst/>
@@ -6158,8 +6158,8 @@
         </p:nvSpPr>
         <p:spPr>
           <a:xfrm>
-            <a:off x="6300216" y="4471416"/>
-            <a:ext cx="5614416" cy="914400"/>
+            <a:off x="6185916" y="4471416"/>
+            <a:ext cx="5500116" cy="914400"/>
           </a:xfrm>
           <a:prstGeom prst="roundRect">
             <a:avLst>
@@ -6192,8 +6192,8 @@
         </p:nvSpPr>
         <p:spPr>
           <a:xfrm>
-            <a:off x="6483096" y="4562856"/>
-            <a:ext cx="5248656" cy="749808"/>
+            <a:off x="6368796" y="4562856"/>
+            <a:ext cx="5134356" cy="749808"/>
           </a:xfrm>
           <a:prstGeom prst="rect">
             <a:avLst/>
@@ -6502,11 +6502,11 @@
         <p:spPr>
           <a:xfrm>
             <a:off x="502920" y="1371600"/>
-            <a:ext cx="2734056" cy="3703320"/>
+            <a:ext cx="2658618" cy="3703320"/>
           </a:xfrm>
           <a:prstGeom prst="roundRect">
             <a:avLst>
-              <a:gd name="adj" fmla="val 2676"/>
+              <a:gd name="adj" fmla="val 2752"/>
             </a:avLst>
           </a:prstGeom>
           <a:solidFill>
@@ -6535,8 +6535,8 @@
         </p:nvSpPr>
         <p:spPr>
           <a:xfrm>
-            <a:off x="667512" y="1481328"/>
-            <a:ext cx="2404872" cy="457200"/>
+            <a:off x="649224" y="1481328"/>
+            <a:ext cx="2366010" cy="457200"/>
           </a:xfrm>
           <a:prstGeom prst="rect">
             <a:avLst/>
@@ -6574,8 +6574,8 @@
         </p:nvSpPr>
         <p:spPr>
           <a:xfrm>
-            <a:off x="667512" y="2011680"/>
-            <a:ext cx="2404872" cy="2926080"/>
+            <a:off x="649224" y="2011680"/>
+            <a:ext cx="2366010" cy="2926080"/>
           </a:xfrm>
           <a:prstGeom prst="rect">
             <a:avLst/>
@@ -6680,12 +6680,12 @@
         </p:nvSpPr>
         <p:spPr>
           <a:xfrm>
-            <a:off x="3419856" y="1371600"/>
-            <a:ext cx="2734056" cy="3703320"/>
+            <a:off x="3344418" y="1371600"/>
+            <a:ext cx="2658618" cy="3703320"/>
           </a:xfrm>
           <a:prstGeom prst="roundRect">
             <a:avLst>
-              <a:gd name="adj" fmla="val 2676"/>
+              <a:gd name="adj" fmla="val 2752"/>
             </a:avLst>
           </a:prstGeom>
           <a:solidFill>
@@ -6714,8 +6714,8 @@
         </p:nvSpPr>
         <p:spPr>
           <a:xfrm>
-            <a:off x="3584448" y="1481328"/>
-            <a:ext cx="2404872" cy="457200"/>
+            <a:off x="3490722" y="1481328"/>
+            <a:ext cx="2366010" cy="457200"/>
           </a:xfrm>
           <a:prstGeom prst="rect">
             <a:avLst/>
@@ -6753,8 +6753,8 @@
         </p:nvSpPr>
         <p:spPr>
           <a:xfrm>
-            <a:off x="3584448" y="2011680"/>
-            <a:ext cx="2404872" cy="2926080"/>
+            <a:off x="3490722" y="2011680"/>
+            <a:ext cx="2366010" cy="2926080"/>
           </a:xfrm>
           <a:prstGeom prst="rect">
             <a:avLst/>
@@ -6859,12 +6859,12 @@
         </p:nvSpPr>
         <p:spPr>
           <a:xfrm>
-            <a:off x="6336792" y="1371600"/>
-            <a:ext cx="2734056" cy="3703320"/>
+            <a:off x="6185916" y="1371600"/>
+            <a:ext cx="2658618" cy="3703320"/>
           </a:xfrm>
           <a:prstGeom prst="roundRect">
             <a:avLst>
-              <a:gd name="adj" fmla="val 2676"/>
+              <a:gd name="adj" fmla="val 2752"/>
             </a:avLst>
           </a:prstGeom>
           <a:solidFill>
@@ -6893,8 +6893,8 @@
         </p:nvSpPr>
         <p:spPr>
           <a:xfrm>
-            <a:off x="6501384" y="1481328"/>
-            <a:ext cx="2404872" cy="457200"/>
+            <a:off x="6332220" y="1481328"/>
+            <a:ext cx="2366010" cy="457200"/>
           </a:xfrm>
           <a:prstGeom prst="rect">
             <a:avLst/>
@@ -6932,8 +6932,8 @@
         </p:nvSpPr>
         <p:spPr>
           <a:xfrm>
-            <a:off x="6501384" y="2011680"/>
-            <a:ext cx="2404872" cy="2926080"/>
+            <a:off x="6332220" y="2011680"/>
+            <a:ext cx="2366010" cy="2926080"/>
           </a:xfrm>
           <a:prstGeom prst="rect">
             <a:avLst/>
@@ -7017,12 +7017,12 @@
         </p:nvSpPr>
         <p:spPr>
           <a:xfrm>
-            <a:off x="9253728" y="1371600"/>
-            <a:ext cx="2734056" cy="3703320"/>
+            <a:off x="9027414" y="1371600"/>
+            <a:ext cx="2658618" cy="3703320"/>
           </a:xfrm>
           <a:prstGeom prst="roundRect">
             <a:avLst>
-              <a:gd name="adj" fmla="val 2676"/>
+              <a:gd name="adj" fmla="val 2752"/>
             </a:avLst>
           </a:prstGeom>
           <a:solidFill>
@@ -7051,8 +7051,8 @@
         </p:nvSpPr>
         <p:spPr>
           <a:xfrm>
-            <a:off x="9418320" y="1481328"/>
-            <a:ext cx="2404872" cy="457200"/>
+            <a:off x="9173718" y="1481328"/>
+            <a:ext cx="2366010" cy="457200"/>
           </a:xfrm>
           <a:prstGeom prst="rect">
             <a:avLst/>
@@ -7090,8 +7090,8 @@
         </p:nvSpPr>
         <p:spPr>
           <a:xfrm>
-            <a:off x="9418320" y="2011680"/>
-            <a:ext cx="2404872" cy="2926080"/>
+            <a:off x="9173718" y="2011680"/>
+            <a:ext cx="2366010" cy="2926080"/>
           </a:xfrm>
           <a:prstGeom prst="rect">
             <a:avLst/>
@@ -7410,11 +7410,11 @@
         <p:spPr>
           <a:xfrm>
             <a:off x="502920" y="1371600"/>
-            <a:ext cx="3785616" cy="3611880"/>
+            <a:ext cx="3605784" cy="3611880"/>
           </a:xfrm>
           <a:prstGeom prst="roundRect">
             <a:avLst>
-              <a:gd name="adj" fmla="val 2532"/>
+              <a:gd name="adj" fmla="val 2536"/>
             </a:avLst>
           </a:prstGeom>
           <a:solidFill>
@@ -7444,7 +7444,7 @@
         <p:spPr>
           <a:xfrm>
             <a:off x="704088" y="1572768"/>
-            <a:ext cx="3383280" cy="457200"/>
+            <a:ext cx="3203448" cy="457200"/>
           </a:xfrm>
           <a:prstGeom prst="rect">
             <a:avLst/>
@@ -7460,7 +7460,7 @@
               <a:buNone/>
             </a:pPr>
             <a:r>
-              <a:rPr lang="en-US" sz="1500" b="1" dirty="0">
+              <a:rPr lang="en-US" sz="1450" b="1" dirty="0">
                 <a:solidFill>
                   <a:srgbClr val="69103F"/>
                 </a:solidFill>
@@ -7470,7 +7470,7 @@
               </a:rPr>
               <a:t>ESSENCIAL · o plano</a:t>
             </a:r>
-            <a:endParaRPr lang="en-US" sz="1500" dirty="0"/>
+            <a:endParaRPr lang="en-US" sz="1450" dirty="0"/>
           </a:p>
         </p:txBody>
       </p:sp>
@@ -7483,7 +7483,7 @@
         <p:spPr>
           <a:xfrm>
             <a:off x="704088" y="2103120"/>
-            <a:ext cx="3383280" cy="2194560"/>
+            <a:ext cx="3203448" cy="2194560"/>
           </a:xfrm>
           <a:prstGeom prst="rect">
             <a:avLst/>
@@ -7610,7 +7610,7 @@
         <p:spPr>
           <a:xfrm>
             <a:off x="704088" y="4434840"/>
-            <a:ext cx="3383280" cy="411480"/>
+            <a:ext cx="3203448" cy="411480"/>
           </a:xfrm>
           <a:prstGeom prst="rect">
             <a:avLst/>
@@ -7648,12 +7648,12 @@
         </p:nvSpPr>
         <p:spPr>
           <a:xfrm>
-            <a:off x="4471416" y="1371600"/>
-            <a:ext cx="3785616" cy="3611880"/>
+            <a:off x="4291584" y="1371600"/>
+            <a:ext cx="3605784" cy="3611880"/>
           </a:xfrm>
           <a:prstGeom prst="roundRect">
             <a:avLst>
-              <a:gd name="adj" fmla="val 2532"/>
+              <a:gd name="adj" fmla="val 2536"/>
             </a:avLst>
           </a:prstGeom>
           <a:solidFill>
@@ -7682,8 +7682,8 @@
         </p:nvSpPr>
         <p:spPr>
           <a:xfrm>
-            <a:off x="4672584" y="1572768"/>
-            <a:ext cx="3383280" cy="457200"/>
+            <a:off x="4492752" y="1572768"/>
+            <a:ext cx="3203448" cy="457200"/>
           </a:xfrm>
           <a:prstGeom prst="rect">
             <a:avLst/>
@@ -7699,7 +7699,7 @@
               <a:buNone/>
             </a:pPr>
             <a:r>
-              <a:rPr lang="en-US" sz="1500" b="1" dirty="0">
+              <a:rPr lang="en-US" sz="1450" b="1" dirty="0">
                 <a:solidFill>
                   <a:srgbClr val="69103F"/>
                 </a:solidFill>
@@ -7709,7 +7709,7 @@
               </a:rPr>
               <a:t>GESTÃO · o plano vivo</a:t>
             </a:r>
-            <a:endParaRPr lang="en-US" sz="1500" dirty="0"/>
+            <a:endParaRPr lang="en-US" sz="1450" dirty="0"/>
           </a:p>
         </p:txBody>
       </p:sp>
@@ -7721,8 +7721,8 @@
         </p:nvSpPr>
         <p:spPr>
           <a:xfrm>
-            <a:off x="4672584" y="2103120"/>
-            <a:ext cx="3383280" cy="2194560"/>
+            <a:off x="4492752" y="2103120"/>
+            <a:ext cx="3203448" cy="2194560"/>
           </a:xfrm>
           <a:prstGeom prst="rect">
             <a:avLst/>
@@ -7869,8 +7869,8 @@
         </p:nvSpPr>
         <p:spPr>
           <a:xfrm>
-            <a:off x="4672584" y="4434840"/>
-            <a:ext cx="3383280" cy="411480"/>
+            <a:off x="4492752" y="4434840"/>
+            <a:ext cx="3203448" cy="411480"/>
           </a:xfrm>
           <a:prstGeom prst="rect">
             <a:avLst/>
@@ -7908,12 +7908,12 @@
         </p:nvSpPr>
         <p:spPr>
           <a:xfrm>
-            <a:off x="8439912" y="1371600"/>
-            <a:ext cx="3785616" cy="3611880"/>
+            <a:off x="8080248" y="1371600"/>
+            <a:ext cx="3605784" cy="3611880"/>
           </a:xfrm>
           <a:prstGeom prst="roundRect">
             <a:avLst>
-              <a:gd name="adj" fmla="val 2532"/>
+              <a:gd name="adj" fmla="val 2536"/>
             </a:avLst>
           </a:prstGeom>
           <a:solidFill>
@@ -7942,8 +7942,8 @@
         </p:nvSpPr>
         <p:spPr>
           <a:xfrm>
-            <a:off x="8641080" y="1572768"/>
-            <a:ext cx="3383280" cy="457200"/>
+            <a:off x="8281416" y="1572768"/>
+            <a:ext cx="3203448" cy="457200"/>
           </a:xfrm>
           <a:prstGeom prst="rect">
             <a:avLst/>
@@ -7959,7 +7959,7 @@
               <a:buNone/>
             </a:pPr>
             <a:r>
-              <a:rPr lang="en-US" sz="1500" b="1" dirty="0">
+              <a:rPr lang="en-US" sz="1450" b="1" dirty="0">
                 <a:solidFill>
                   <a:srgbClr val="69103F"/>
                 </a:solidFill>
@@ -7969,7 +7969,7 @@
               </a:rPr>
               <a:t>INTEGRAL · plano, ativação e defesa</a:t>
             </a:r>
-            <a:endParaRPr lang="en-US" sz="1500" dirty="0"/>
+            <a:endParaRPr lang="en-US" sz="1450" dirty="0"/>
           </a:p>
         </p:txBody>
       </p:sp>
@@ -7981,8 +7981,8 @@
         </p:nvSpPr>
         <p:spPr>
           <a:xfrm>
-            <a:off x="8641080" y="2103120"/>
-            <a:ext cx="3383280" cy="2194560"/>
+            <a:off x="8281416" y="2103120"/>
+            <a:ext cx="3203448" cy="2194560"/>
           </a:xfrm>
           <a:prstGeom prst="rect">
             <a:avLst/>
@@ -8108,8 +8108,8 @@
         </p:nvSpPr>
         <p:spPr>
           <a:xfrm>
-            <a:off x="8641080" y="4434840"/>
-            <a:ext cx="3383280" cy="411480"/>
+            <a:off x="8281416" y="4434840"/>
+            <a:ext cx="3203448" cy="411480"/>
           </a:xfrm>
           <a:prstGeom prst="rect">
             <a:avLst/>

</xml_diff>

<commit_message>
Jurisprudencia: reverifica os 4 precedentes em fonte oficial do STJ
- Links oficiais gravados no dossie, por precedente
- CORRIGE a data do REsp 2.220.333: 07/10/2025 estava errado; a noticia
  oficial e de 13/11/2025 e nao informa a data de julgamento
- Deck e painel passam a citar numero + Turma + relator + ano; dia e mes
  so em peca, apos conferencia no acordao
- Acrescenta o art. 7o da Lei 12.865/2013 como base da extensao as IPs
</commit_message>
<xml_diff>
--- a/Deck-Plano-Contingencia-LBCA.pptx
+++ b/Deck-Plano-Contingencia-LBCA.pptx
@@ -2224,7 +2224,7 @@
                 <a:ea typeface="Arial" pitchFamily="34" charset="-122"/>
                 <a:cs typeface="Arial" pitchFamily="34" charset="-120"/>
               </a:rPr>
-              <a:t>REsp 1.995.458/SP · 3ª T · 9/8/2022</a:t>
+              <a:t>REsp 1.995.458/SP · 3ª T · rel. Nancy Andrighi · 2022</a:t>
             </a:r>
             <a:endParaRPr lang="en-US" sz="1100" dirty="0"/>
           </a:p>
@@ -2297,7 +2297,7 @@
                 <a:ea typeface="Arial" pitchFamily="34" charset="-122"/>
                 <a:cs typeface="Arial" pitchFamily="34" charset="-120"/>
               </a:rPr>
-              <a:t>Falha de detecção fora do perfil — alcança as IPs
+              <a:t>Falha de detecção fora do perfil — alcança as IPs (art. 7º da Lei 12.865/2013)
 </a:t>
             </a:r>
             <a:pPr indent="0" marL="0">
@@ -2312,7 +2312,7 @@
                 <a:ea typeface="Arial" pitchFamily="34" charset="-122"/>
                 <a:cs typeface="Arial" pitchFamily="34" charset="-120"/>
               </a:rPr>
-              <a:t>REsp 2.222.059/SP e 2.229.519/DF · 3ª T · 7/10/2025</a:t>
+              <a:t>REsp 2.222.059 e 2.229.519 · 3ª T · rel. Villas Bôas Cueva · 2025</a:t>
             </a:r>
             <a:endParaRPr lang="en-US" sz="1100" dirty="0"/>
           </a:p>
@@ -2400,7 +2400,7 @@
                 <a:ea typeface="Arial" pitchFamily="34" charset="-122"/>
                 <a:cs typeface="Arial" pitchFamily="34" charset="-120"/>
               </a:rPr>
-              <a:t>REsp 2.077.278/SP · 3ª T · 3/10/2023</a:t>
+              <a:t>REsp 2.077.278/SP · 3ª T · rel. Nancy Andrighi · 2023 · Inf. 791</a:t>
             </a:r>
             <a:endParaRPr lang="en-US" sz="1100" dirty="0"/>
           </a:p>
@@ -2473,7 +2473,7 @@
                 <a:ea typeface="Arial" pitchFamily="34" charset="-122"/>
                 <a:cs typeface="Arial" pitchFamily="34" charset="-120"/>
               </a:rPr>
-              <a:t>Havendo falha, resposta integral: vítima induzida não assume risco
+              <a:t>Havendo falha, reparação integral: vítima induzida não assume risco
 </a:t>
             </a:r>
             <a:pPr indent="0" marL="0">
@@ -2488,7 +2488,7 @@
                 <a:ea typeface="Arial" pitchFamily="34" charset="-122"/>
                 <a:cs typeface="Arial" pitchFamily="34" charset="-120"/>
               </a:rPr>
-              <a:t>REsp 2.220.333/DF · 3ª T · 7/10/2025</a:t>
+              <a:t>REsp 2.220.333 · 3ª T · rel. Villas Bôas Cueva · 2025</a:t>
             </a:r>
             <a:endParaRPr lang="en-US" sz="1100" dirty="0"/>
           </a:p>
@@ -2541,7 +2541,7 @@
                 <a:ea typeface="Arial" pitchFamily="34" charset="-122"/>
                 <a:cs typeface="Arial" pitchFamily="34" charset="-120"/>
               </a:rPr>
-              <a:t>o prestador que apenas hospeda a conta usada no golpe só responde se demonstrada falta de diligência na abertura ou manutenção (REsp 2.124.423, 3ª Turma, 27/1/2025) — a diligência documentada é a própria defesa.</a:t>
+              <a:t>o prestador que apenas hospeda a conta usada no golpe só responde se demonstrada falta de diligência na abertura ou manutenção (REsp 2.124.423, 3ª Turma, rel. Nancy Andrighi) — a diligência documentada é a própria defesa.</a:t>
             </a:r>
             <a:endParaRPr lang="en-US" sz="1150" dirty="0"/>
           </a:p>

</xml_diff>